<commit_message>
Creator and editor forms open in a right-hand panel that persists
- Every form (openForm and data-entry dialogs) opens as a panel docked at
  the right of the workspace; the page stays usable beside it.
- Clicking outside or pressing Esc never closes a panel; only x / Close do.
- Open panels are remembered in the browser tab and reopen after a refresh
  or signing in again, with their entries (server drafts, or a tab copy for
  forms without drafts).
- After a successful save the panel stays open, locked, showing "Saved"
  until the user closes it.
- Side panels no longer close on an outside click once something is typed.
- Inline form handlers moved into named functions so they can be reopened.
- UI test for the panel behaviour; user manual 1.8 and deck updated.

Co-Authored-By: Claude Opus 5.5 <noreply@anthropic.com>
Claude-Session: https://claude.ai/code/session_01BCzcS7kB9PYn4XhtsXF9GJ
</commit_message>
<xml_diff>
--- a/docs/Usermanual.pptx
+++ b/docs/Usermanual.pptx
@@ -138,7 +138,7 @@
   <p:extLst>
     <p:ext uri="{521415D9-36F7-43E2-AB2F-B90AF26B5E84}">
       <p14:sectionLst xmlns:p14="http://schemas.microsoft.com/office/powerpoint/2010/main">
-        <p14:section name="Introduction" id="{6c305bc2-f3bc-82e9-c7f9-c8fcf31f35bd}">
+        <p14:section name="Introduction" id="{fbaa3c05-c23c-9613-6f9e-fc75ff3971b3}">
           <p14:sldIdLst>
             <p14:sldId id="256"/>
             <p14:sldId id="257"/>
@@ -146,7 +146,7 @@
             <p14:sldId id="259"/>
           </p14:sldIdLst>
         </p14:section>
-        <p14:section name="Who does what" id="{d8afb770-24f0-0878-c5d7-2f08598bce32}">
+        <p14:section name="Who does what" id="{db3084cb-25a1-1a85-72d3-1cd48af6003f}">
           <p14:sldIdLst>
             <p14:sldId id="260"/>
             <p14:sldId id="261"/>
@@ -155,7 +155,7 @@
             <p14:sldId id="264"/>
           </p14:sldIdLst>
         </p14:section>
-        <p14:section name="Getting started" id="{99607308-33b9-b09e-0814-f8167497e78f}">
+        <p14:section name="Getting started" id="{d5fae000-890f-f99a-68a8-5390acdf8965}">
           <p14:sldIdLst>
             <p14:sldId id="265"/>
             <p14:sldId id="266"/>
@@ -163,7 +163,7 @@
             <p14:sldId id="268"/>
           </p14:sldIdLst>
         </p14:section>
-        <p14:section name="Plan the year" id="{fb8b4813-9cd9-d039-69f2-4a6aff2afc87}">
+        <p14:section name="Plan the year" id="{b15e439e-dacf-e30c-9e39-f2f84ca08232}">
           <p14:sldIdLst>
             <p14:sldId id="269"/>
             <p14:sldId id="270"/>
@@ -171,7 +171,7 @@
             <p14:sldId id="272"/>
           </p14:sldIdLst>
         </p14:section>
-        <p14:section name="Perform the audit" id="{4a9c82f7-6f21-5bea-6a7c-8482cc3535e6}">
+        <p14:section name="Perform the audit" id="{08a6d68d-dbb3-44cc-bd82-cbaa73500bb3}">
           <p14:sldIdLst>
             <p14:sldId id="273"/>
             <p14:sldId id="274"/>
@@ -180,7 +180,7 @@
             <p14:sldId id="277"/>
           </p14:sldIdLst>
         </p14:section>
-        <p14:section name="Report and follow up" id="{588a3874-7515-3aec-1cd9-a1f05932014e}">
+        <p14:section name="Report and follow up" id="{b94080f9-1085-537e-94db-88737c4c8003}">
           <p14:sldIdLst>
             <p14:sldId id="278"/>
             <p14:sldId id="279"/>
@@ -188,14 +188,14 @@
             <p14:sldId id="281"/>
           </p14:sldIdLst>
         </p14:section>
-        <p14:section name="Governance and quality" id="{37fb918f-aaff-37bf-f016-4fad157b29da}">
+        <p14:section name="Governance and quality" id="{45430586-c7d5-6d14-64c7-1da446d2d14c}">
           <p14:sldIdLst>
             <p14:sldId id="282"/>
             <p14:sldId id="283"/>
             <p14:sldId id="284"/>
           </p14:sldIdLst>
         </p14:section>
-        <p14:section name="Auditees and quick reference" id="{f5e338b1-73fa-e077-9931-4334ea77059c}">
+        <p14:section name="Auditees and quick reference" id="{fb61684f-fe03-e5b3-7bbc-7e19ebe0653a}">
           <p14:sldIdLst>
             <p14:sldId id="285"/>
             <p14:sldId id="286"/>
@@ -5675,7 +5675,7 @@
                   <a:schemeClr val="tx1"/>
                 </a:solidFill>
               </a:rPr>
-              <a:t>Required fields marked *, plain-language errors, automatic drafts you can restore</a:t>
+              <a:t>Open in a right-hand panel that stays open until you close it, even after a refresh; drafts save as you type</a:t>
             </a:r>
             <a:endParaRPr lang="en-US" sz="1400" dirty="0"/>
           </a:p>
@@ -16906,7 +16906,7 @@
                   <a:schemeClr val="tx1"/>
                 </a:solidFill>
               </a:rPr>
-              <a:t>Drafts are saved as you type</a:t>
+              <a:t>Panels stay open; drafts save as you type</a:t>
             </a:r>
             <a:endParaRPr lang="en-US" sz="1400" dirty="0"/>
           </a:p>

</xml_diff>